<commit_message>
L5 Pitch Deck: Add Video Walkthrough link to Slide 12 and regenerate PPTX
</commit_message>
<xml_diff>
--- a/Lumenova_Pitch_Deck.pptx
+++ b/Lumenova_Pitch_Deck.pptx
@@ -4930,7 +4930,7 @@
         <p:spPr>
           <a:xfrm>
             <a:off x="914400" y="3657600"/>
-            <a:ext cx="3108960" cy="2011680"/>
+            <a:ext cx="2377440" cy="2011680"/>
           </a:xfrm>
           <a:prstGeom prst="roundRect">
             <a:avLst/>
@@ -4975,7 +4975,7 @@
         <p:spPr>
           <a:xfrm>
             <a:off x="1051560" y="3840480"/>
-            <a:ext cx="2834640" cy="365760"/>
+            <a:ext cx="2103120" cy="365760"/>
           </a:xfrm>
           <a:prstGeom prst="rect">
             <a:avLst/>
@@ -4989,7 +4989,7 @@
           <a:lstStyle/>
           <a:p>
             <a:pPr algn="ctr">
-              <a:defRPr sz="1500" b="1">
+              <a:defRPr sz="1400" b="1">
                 <a:solidFill>
                   <a:srgbClr val="06B6D4"/>
                 </a:solidFill>
@@ -5011,7 +5011,7 @@
         <p:spPr>
           <a:xfrm>
             <a:off x="1051560" y="4297680"/>
-            <a:ext cx="2834640" cy="1097280"/>
+            <a:ext cx="2103120" cy="1097280"/>
           </a:xfrm>
           <a:prstGeom prst="rect">
             <a:avLst/>
@@ -5025,7 +5025,7 @@
           <a:lstStyle/>
           <a:p>
             <a:pPr algn="ctr">
-              <a:defRPr sz="1200" b="0">
+              <a:defRPr sz="1100" b="0">
                 <a:solidFill>
                   <a:srgbClr val="A0AEC0"/>
                 </a:solidFill>
@@ -5051,8 +5051,8 @@
         </p:nvSpPr>
         <p:spPr>
           <a:xfrm>
-            <a:off x="4480560" y="3657600"/>
-            <a:ext cx="3108960" cy="2011680"/>
+            <a:off x="3566160" y="3657600"/>
+            <a:ext cx="2377440" cy="2011680"/>
           </a:xfrm>
           <a:prstGeom prst="roundRect">
             <a:avLst/>
@@ -5096,8 +5096,8 @@
         </p:nvSpPr>
         <p:spPr>
           <a:xfrm>
-            <a:off x="4617720" y="3840480"/>
-            <a:ext cx="2834640" cy="365760"/>
+            <a:off x="3703320" y="3840480"/>
+            <a:ext cx="2103120" cy="365760"/>
           </a:xfrm>
           <a:prstGeom prst="rect">
             <a:avLst/>
@@ -5111,7 +5111,7 @@
           <a:lstStyle/>
           <a:p>
             <a:pPr algn="ctr">
-              <a:defRPr sz="1500" b="1">
+              <a:defRPr sz="1400" b="1">
                 <a:solidFill>
                   <a:srgbClr val="F59E0B"/>
                 </a:solidFill>
@@ -5132,8 +5132,8 @@
         </p:nvSpPr>
         <p:spPr>
           <a:xfrm>
-            <a:off x="4617720" y="4297680"/>
-            <a:ext cx="2834640" cy="1097280"/>
+            <a:off x="3703320" y="4297680"/>
+            <a:ext cx="2103120" cy="1097280"/>
           </a:xfrm>
           <a:prstGeom prst="rect">
             <a:avLst/>
@@ -5147,7 +5147,7 @@
           <a:lstStyle/>
           <a:p>
             <a:pPr algn="ctr">
-              <a:defRPr sz="1200" b="0">
+              <a:defRPr sz="1100" b="0">
                 <a:solidFill>
                   <a:srgbClr val="A0AEC0"/>
                 </a:solidFill>
@@ -5173,8 +5173,8 @@
         </p:nvSpPr>
         <p:spPr>
           <a:xfrm>
-            <a:off x="8046720" y="3657600"/>
-            <a:ext cx="3108960" cy="2011680"/>
+            <a:off x="6217920" y="3657600"/>
+            <a:ext cx="2377440" cy="2011680"/>
           </a:xfrm>
           <a:prstGeom prst="roundRect">
             <a:avLst/>
@@ -5218,8 +5218,8 @@
         </p:nvSpPr>
         <p:spPr>
           <a:xfrm>
-            <a:off x="8183880" y="3840480"/>
-            <a:ext cx="2834640" cy="365760"/>
+            <a:off x="6355080" y="3840480"/>
+            <a:ext cx="2103120" cy="365760"/>
           </a:xfrm>
           <a:prstGeom prst="rect">
             <a:avLst/>
@@ -5233,15 +5233,15 @@
           <a:lstStyle/>
           <a:p>
             <a:pPr algn="ctr">
-              <a:defRPr sz="1500" b="1">
-                <a:solidFill>
-                  <a:srgbClr val="06B6D4"/>
+              <a:defRPr sz="1400" b="1">
+                <a:solidFill>
+                  <a:srgbClr val="F59E0B"/>
                 </a:solidFill>
                 <a:latin typeface="Segoe UI"/>
               </a:defRPr>
             </a:pPr>
             <a:r>
-              <a:t>Developer Contact</a:t>
+              <a:t>Video Walkthrough</a:t>
             </a:r>
           </a:p>
         </p:txBody>
@@ -5254,8 +5254,8 @@
         </p:nvSpPr>
         <p:spPr>
           <a:xfrm>
-            <a:off x="8183880" y="4297680"/>
-            <a:ext cx="2834640" cy="1097280"/>
+            <a:off x="6355080" y="4297680"/>
+            <a:ext cx="2103120" cy="1097280"/>
           </a:xfrm>
           <a:prstGeom prst="rect">
             <a:avLst/>
@@ -5269,7 +5269,129 @@
           <a:lstStyle/>
           <a:p>
             <a:pPr algn="ctr">
-              <a:defRPr sz="1200" b="0">
+              <a:defRPr sz="1100" b="0">
+                <a:solidFill>
+                  <a:srgbClr val="A0AEC0"/>
+                </a:solidFill>
+                <a:latin typeface="Segoe UI"/>
+              </a:defRPr>
+            </a:pPr>
+            <a:r>
+              <a:t>youtu.be/WZeQO9A-DmE</a:t>
+            </a:r>
+            <a:br/>
+            <a:br/>
+            <a:r>
+              <a:t>[ Watch Demo Video ]</a:t>
+            </a:r>
+          </a:p>
+        </p:txBody>
+      </p:sp>
+      <p:sp>
+        <p:nvSpPr>
+          <p:cNvPr id="13" name="Rounded Rectangle 12"/>
+          <p:cNvSpPr/>
+          <p:nvPr/>
+        </p:nvSpPr>
+        <p:spPr>
+          <a:xfrm>
+            <a:off x="8869680" y="3657600"/>
+            <a:ext cx="2377440" cy="2011680"/>
+          </a:xfrm>
+          <a:prstGeom prst="roundRect">
+            <a:avLst/>
+          </a:prstGeom>
+          <a:solidFill>
+            <a:srgbClr val="121929"/>
+          </a:solidFill>
+          <a:ln w="19050">
+            <a:solidFill>
+              <a:srgbClr val="1E293B"/>
+            </a:solidFill>
+          </a:ln>
+        </p:spPr>
+        <p:style>
+          <a:lnRef idx="1">
+            <a:schemeClr val="accent1"/>
+          </a:lnRef>
+          <a:fillRef idx="3">
+            <a:schemeClr val="accent1"/>
+          </a:fillRef>
+          <a:effectRef idx="2">
+            <a:schemeClr val="accent1"/>
+          </a:effectRef>
+          <a:fontRef idx="minor">
+            <a:schemeClr val="lt1"/>
+          </a:fontRef>
+        </p:style>
+        <p:txBody>
+          <a:bodyPr rtlCol="0" anchor="ctr"/>
+          <a:lstStyle/>
+          <a:p>
+            <a:pPr algn="ctr"/>
+          </a:p>
+        </p:txBody>
+      </p:sp>
+      <p:sp>
+        <p:nvSpPr>
+          <p:cNvPr id="14" name="TextBox 13"/>
+          <p:cNvSpPr txBox="1"/>
+          <p:nvPr/>
+        </p:nvSpPr>
+        <p:spPr>
+          <a:xfrm>
+            <a:off x="9006840" y="3840480"/>
+            <a:ext cx="2103120" cy="365760"/>
+          </a:xfrm>
+          <a:prstGeom prst="rect">
+            <a:avLst/>
+          </a:prstGeom>
+          <a:noFill/>
+        </p:spPr>
+        <p:txBody>
+          <a:bodyPr wrap="square">
+            <a:spAutoFit/>
+          </a:bodyPr>
+          <a:lstStyle/>
+          <a:p>
+            <a:pPr algn="ctr">
+              <a:defRPr sz="1400" b="1">
+                <a:solidFill>
+                  <a:srgbClr val="06B6D4"/>
+                </a:solidFill>
+                <a:latin typeface="Segoe UI"/>
+              </a:defRPr>
+            </a:pPr>
+            <a:r>
+              <a:t>Developer Contact</a:t>
+            </a:r>
+          </a:p>
+        </p:txBody>
+      </p:sp>
+      <p:sp>
+        <p:nvSpPr>
+          <p:cNvPr id="15" name="TextBox 14"/>
+          <p:cNvSpPr txBox="1"/>
+          <p:nvPr/>
+        </p:nvSpPr>
+        <p:spPr>
+          <a:xfrm>
+            <a:off x="9006840" y="4297680"/>
+            <a:ext cx="2103120" cy="1097280"/>
+          </a:xfrm>
+          <a:prstGeom prst="rect">
+            <a:avLst/>
+          </a:prstGeom>
+          <a:noFill/>
+        </p:spPr>
+        <p:txBody>
+          <a:bodyPr wrap="square">
+            <a:spAutoFit/>
+          </a:bodyPr>
+          <a:lstStyle/>
+          <a:p>
+            <a:pPr algn="ctr">
+              <a:defRPr sz="1100" b="0">
                 <a:solidFill>
                   <a:srgbClr val="A0AEC0"/>
                 </a:solidFill>

</xml_diff>